<commit_message>
changed some of the verbage to make it more general than just the house of hope. changed the marj filter to indicate its positive correlation.
</commit_message>
<xml_diff>
--- a/matthew_house_of_hope_slides.pptx
+++ b/matthew_house_of_hope_slides.pptx
@@ -131,14 +131,6 @@
 <p188:authorLst xmlns:a="http://schemas.openxmlformats.org/drawingml/2006/main" xmlns:r="http://schemas.openxmlformats.org/officeDocument/2006/relationships" xmlns:p188="http://schemas.microsoft.com/office/powerpoint/2018/8/main">
   <p188:author id="{00000000-0000-0000-0000-000000000000}" name="Author" initials="A" userId="Author" providerId="AD"/>
 </p188:authorLst>
-</file>
-
-<file path=ppt/revisionInfo.xml><?xml version="1.0" encoding="utf-8"?>
-<p1510:revInfo xmlns:a="http://schemas.openxmlformats.org/drawingml/2006/main" xmlns:r="http://schemas.openxmlformats.org/officeDocument/2006/relationships" xmlns:p1510="http://schemas.microsoft.com/office/powerpoint/2015/10/main">
-  <p1510:revLst>
-    <p1510:client id="{ED71470D-C100-4DCC-880C-DA7C49F84EF5}" v="5" dt="2024-08-01T19:32:30.804"/>
-  </p1510:revLst>
-</p1510:revInfo>
 </file>
 
 <file path=ppt/changesInfos/changesInfo1.xml><?xml version="1.0" encoding="utf-8"?>
@@ -497,8 +489,8 @@
   </pc:docChgLst>
   <pc:docChgLst>
     <pc:chgData name="Matt Watkins" userId="8f390d74bad77d8d" providerId="LiveId" clId="{9C1A2300-6861-4C47-B36C-71BDA40ABBE3}"/>
-    <pc:docChg chg="modSld">
-      <pc:chgData name="Matt Watkins" userId="8f390d74bad77d8d" providerId="LiveId" clId="{9C1A2300-6861-4C47-B36C-71BDA40ABBE3}" dt="2024-08-01T22:47:29.129" v="92" actId="1076"/>
+    <pc:docChg chg="custSel modSld">
+      <pc:chgData name="Matt Watkins" userId="8f390d74bad77d8d" providerId="LiveId" clId="{9C1A2300-6861-4C47-B36C-71BDA40ABBE3}" dt="2024-08-19T00:51:03.758" v="292" actId="20577"/>
       <pc:docMkLst>
         <pc:docMk/>
       </pc:docMkLst>
@@ -532,6 +524,21 @@
           </ac:spMkLst>
         </pc:spChg>
       </pc:sldChg>
+      <pc:sldChg chg="modSp mod">
+        <pc:chgData name="Matt Watkins" userId="8f390d74bad77d8d" providerId="LiveId" clId="{9C1A2300-6861-4C47-B36C-71BDA40ABBE3}" dt="2024-08-19T00:51:03.758" v="292" actId="20577"/>
+        <pc:sldMkLst>
+          <pc:docMk/>
+          <pc:sldMk cId="3748721295" sldId="298"/>
+        </pc:sldMkLst>
+        <pc:spChg chg="mod">
+          <ac:chgData name="Matt Watkins" userId="8f390d74bad77d8d" providerId="LiveId" clId="{9C1A2300-6861-4C47-B36C-71BDA40ABBE3}" dt="2024-08-19T00:51:03.758" v="292" actId="20577"/>
+          <ac:spMkLst>
+            <pc:docMk/>
+            <pc:sldMk cId="3748721295" sldId="298"/>
+            <ac:spMk id="4" creationId="{ACFBB810-3430-2C29-1AA0-9744AA0A1AA3}"/>
+          </ac:spMkLst>
+        </pc:spChg>
+      </pc:sldChg>
     </pc:docChg>
   </pc:docChgLst>
 </pc:chgInfo>
@@ -631,7 +638,7 @@
           <a:p>
             <a:fld id="{7B97C6B7-F63D-48F8-8C65-A57506B0F13B}" type="datetimeFigureOut">
               <a:rPr lang="en-US" smtClean="0"/>
-              <a:t>8/1/2024</a:t>
+              <a:t>8/18/2024</a:t>
             </a:fld>
             <a:endParaRPr lang="en-US" dirty="0"/>
           </a:p>
@@ -808,7 +815,7 @@
           <a:p>
             <a:fld id="{AC09A0FA-2191-4F92-A1E4-6EB4598AC4EC}" type="datetimeFigureOut">
               <a:rPr lang="en-US" smtClean="0"/>
-              <a:t>8/1/2024</a:t>
+              <a:t>8/15/2024</a:t>
             </a:fld>
             <a:endParaRPr lang="en-US" dirty="0"/>
           </a:p>
@@ -8101,16 +8108,37 @@
           <a:p>
             <a:r>
               <a:rPr lang="en-US" sz="2000" b="1" dirty="0"/>
-              <a:t>The MLPClassifier, (Multi-layer Perceptron Classifier) is a neural network that uses a supervised learning algorithm to classify data by predicting which category an input belongs to.</a:t>
-            </a:r>
-          </a:p>
-          <a:p>
-            <a:endParaRPr lang="en-US" sz="2000" b="1" dirty="0"/>
-          </a:p>
-          <a:p>
+              <a:t>The </a:t>
+            </a:r>
+            <a:r>
+              <a:rPr lang="en-US" sz="2000" b="1" dirty="0" err="1"/>
+              <a:t>Gradiant</a:t>
+            </a:r>
             <a:r>
               <a:rPr lang="en-US" sz="2000" b="1" dirty="0"/>
-              <a:t>The input, in this case, is the survey questions. MLPClassifier worked well for this with 100 hidden layers as the dataset would have 33 columns of data that it was ingesting to make a prediction of success and provide helpful success statistics.</a:t>
+              <a:t> Boosting Machine Classifier combines the accuracy of a neural network with the simplicity of a classifier and produces the same accuracy in 1/5</a:t>
+            </a:r>
+            <a:r>
+              <a:rPr lang="en-US" sz="2000" b="1" baseline="30000" dirty="0"/>
+              <a:t>th</a:t>
+            </a:r>
+            <a:r>
+              <a:rPr lang="en-US" sz="2000" b="1" dirty="0"/>
+              <a:t> of the time.</a:t>
+            </a:r>
+          </a:p>
+          <a:p>
+            <a:r>
+              <a:rPr lang="en-US" sz="2000" b="1" dirty="0"/>
+              <a:t>The input, in this case, is the survey questions. </a:t>
+            </a:r>
+            <a:r>
+              <a:rPr lang="en-US" sz="2000" b="1" dirty="0" err="1"/>
+              <a:t>GBMClassifier</a:t>
+            </a:r>
+            <a:r>
+              <a:rPr lang="en-US" sz="2000" b="1" dirty="0"/>
+              <a:t> worked well for this with 100 hidden layers as the dataset would have 33 columns of data that it was ingesting to make a prediction of success and provide helpful success statistics.</a:t>
             </a:r>
           </a:p>
           <a:p>
@@ -9024,6 +9052,26 @@
 </file>
 
 <file path=customXml/item1.xml><?xml version="1.0" encoding="utf-8"?>
+<p:properties xmlns:p="http://schemas.microsoft.com/office/2006/metadata/properties" xmlns:xsi="http://www.w3.org/2001/XMLSchema-instance" xmlns:pc="http://schemas.microsoft.com/office/infopath/2007/PartnerControls">
+  <documentManagement>
+    <_ip_UnifiedCompliancePolicyUIAction xmlns="http://schemas.microsoft.com/sharepoint/v3" xsi:nil="true"/>
+    <Image xmlns="71af3243-3dd4-4a8d-8c0d-dd76da1f02a5">
+      <Url xsi:nil="true"/>
+      <Description xsi:nil="true"/>
+    </Image>
+    <Status xmlns="71af3243-3dd4-4a8d-8c0d-dd76da1f02a5">Not started</Status>
+    <Background xmlns="71af3243-3dd4-4a8d-8c0d-dd76da1f02a5">false</Background>
+    <_ip_UnifiedCompliancePolicyProperties xmlns="http://schemas.microsoft.com/sharepoint/v3" xsi:nil="true"/>
+    <ImageTagsTaxHTField xmlns="71af3243-3dd4-4a8d-8c0d-dd76da1f02a5">
+      <Terms xmlns="http://schemas.microsoft.com/office/infopath/2007/PartnerControls"/>
+    </ImageTagsTaxHTField>
+    <TaxCatchAll xmlns="230e9df3-be65-4c73-a93b-d1236ebd677e" xsi:nil="true"/>
+    <MediaServiceKeyPoints xmlns="71af3243-3dd4-4a8d-8c0d-dd76da1f02a5" xsi:nil="true"/>
+  </documentManagement>
+</p:properties>
+</file>
+
+<file path=customXml/item2.xml><?xml version="1.0" encoding="utf-8"?>
 <ct:contentTypeSchema xmlns:ct="http://schemas.microsoft.com/office/2006/metadata/contentType" xmlns:ma="http://schemas.microsoft.com/office/2006/metadata/properties/metaAttributes" ct:_="" ma:_="" ma:contentTypeName="Document" ma:contentTypeID="0x01010079F111ED35F8CC479449609E8A0923A6" ma:contentTypeVersion="28" ma:contentTypeDescription="Create a new document." ma:contentTypeScope="" ma:versionID="60f5a4f2d2b0abadcf532d48ebf9cb71">
   <xsd:schema xmlns:xsd="http://www.w3.org/2001/XMLSchema" xmlns:xs="http://www.w3.org/2001/XMLSchema" xmlns:p="http://schemas.microsoft.com/office/2006/metadata/properties" xmlns:ns1="http://schemas.microsoft.com/sharepoint/v3" xmlns:ns2="71af3243-3dd4-4a8d-8c0d-dd76da1f02a5" xmlns:ns3="16c05727-aa75-4e4a-9b5f-8a80a1165891" xmlns:ns4="230e9df3-be65-4c73-a93b-d1236ebd677e" targetNamespace="http://schemas.microsoft.com/office/2006/metadata/properties" ma:root="true" ma:fieldsID="7dd78129e6a1811f84807ad11c651531" ns1:_="" ns2:_="" ns3:_="" ns4:_="">
     <xsd:import namespace="http://schemas.microsoft.com/sharepoint/v3"/>
@@ -9335,26 +9383,6 @@
 </ct:contentTypeSchema>
 </file>
 
-<file path=customXml/item2.xml><?xml version="1.0" encoding="utf-8"?>
-<p:properties xmlns:p="http://schemas.microsoft.com/office/2006/metadata/properties" xmlns:xsi="http://www.w3.org/2001/XMLSchema-instance" xmlns:pc="http://schemas.microsoft.com/office/infopath/2007/PartnerControls">
-  <documentManagement>
-    <_ip_UnifiedCompliancePolicyUIAction xmlns="http://schemas.microsoft.com/sharepoint/v3" xsi:nil="true"/>
-    <Image xmlns="71af3243-3dd4-4a8d-8c0d-dd76da1f02a5">
-      <Url xsi:nil="true"/>
-      <Description xsi:nil="true"/>
-    </Image>
-    <Status xmlns="71af3243-3dd4-4a8d-8c0d-dd76da1f02a5">Not started</Status>
-    <Background xmlns="71af3243-3dd4-4a8d-8c0d-dd76da1f02a5">false</Background>
-    <_ip_UnifiedCompliancePolicyProperties xmlns="http://schemas.microsoft.com/sharepoint/v3" xsi:nil="true"/>
-    <ImageTagsTaxHTField xmlns="71af3243-3dd4-4a8d-8c0d-dd76da1f02a5">
-      <Terms xmlns="http://schemas.microsoft.com/office/infopath/2007/PartnerControls"/>
-    </ImageTagsTaxHTField>
-    <TaxCatchAll xmlns="230e9df3-be65-4c73-a93b-d1236ebd677e" xsi:nil="true"/>
-    <MediaServiceKeyPoints xmlns="71af3243-3dd4-4a8d-8c0d-dd76da1f02a5" xsi:nil="true"/>
-  </documentManagement>
-</p:properties>
-</file>
-
 <file path=customXml/item3.xml><?xml version="1.0" encoding="utf-8"?>
 <?mso-contentType ?>
 <FormTemplates xmlns="http://schemas.microsoft.com/sharepoint/v3/contenttype/forms">
@@ -9365,6 +9393,18 @@
 </file>
 
 <file path=customXml/itemProps1.xml><?xml version="1.0" encoding="utf-8"?>
+<ds:datastoreItem xmlns:ds="http://schemas.openxmlformats.org/officeDocument/2006/customXml" ds:itemID="{5A00B2AC-C335-4100-B8B3-2D9F49A72906}">
+  <ds:schemaRefs>
+    <ds:schemaRef ds:uri="http://schemas.microsoft.com/office/2006/metadata/properties"/>
+    <ds:schemaRef ds:uri="http://schemas.microsoft.com/office/infopath/2007/PartnerControls"/>
+    <ds:schemaRef ds:uri="http://schemas.microsoft.com/sharepoint/v3"/>
+    <ds:schemaRef ds:uri="71af3243-3dd4-4a8d-8c0d-dd76da1f02a5"/>
+    <ds:schemaRef ds:uri="230e9df3-be65-4c73-a93b-d1236ebd677e"/>
+  </ds:schemaRefs>
+</ds:datastoreItem>
+</file>
+
+<file path=customXml/itemProps2.xml><?xml version="1.0" encoding="utf-8"?>
 <ds:datastoreItem xmlns:ds="http://schemas.openxmlformats.org/officeDocument/2006/customXml" ds:itemID="{0037C456-A6DA-4DEE-A3FB-4EC3058FD086}">
   <ds:schemaRefs>
     <ds:schemaRef ds:uri="http://schemas.microsoft.com/office/2006/metadata/contentType"/>
@@ -9385,18 +9425,6 @@
 </ds:datastoreItem>
 </file>
 
-<file path=customXml/itemProps2.xml><?xml version="1.0" encoding="utf-8"?>
-<ds:datastoreItem xmlns:ds="http://schemas.openxmlformats.org/officeDocument/2006/customXml" ds:itemID="{5A00B2AC-C335-4100-B8B3-2D9F49A72906}">
-  <ds:schemaRefs>
-    <ds:schemaRef ds:uri="http://schemas.microsoft.com/office/2006/metadata/properties"/>
-    <ds:schemaRef ds:uri="http://schemas.microsoft.com/office/infopath/2007/PartnerControls"/>
-    <ds:schemaRef ds:uri="http://schemas.microsoft.com/sharepoint/v3"/>
-    <ds:schemaRef ds:uri="71af3243-3dd4-4a8d-8c0d-dd76da1f02a5"/>
-    <ds:schemaRef ds:uri="230e9df3-be65-4c73-a93b-d1236ebd677e"/>
-  </ds:schemaRefs>
-</ds:datastoreItem>
-</file>
-
 <file path=customXml/itemProps3.xml><?xml version="1.0" encoding="utf-8"?>
 <ds:datastoreItem xmlns:ds="http://schemas.openxmlformats.org/officeDocument/2006/customXml" ds:itemID="{19D1F84C-D1FD-4B1B-9CFD-8E0D96AC4DF2}">
   <ds:schemaRefs>

</xml_diff>